<commit_message>
Added link to hosted app
</commit_message>
<xml_diff>
--- a/Presentation.pptx
+++ b/Presentation.pptx
@@ -4865,20 +4865,22 @@
             </a:r>
           </a:p>
           <a:p>
-            <a:pPr marL="457200" indent="-457200">
-              <a:buAutoNum type="arabicPeriod"/>
+            <a:pPr marL="0" indent="0">
+              <a:buNone/>
             </a:pPr>
-            <a:endParaRPr lang="en-US" dirty="0"/>
+            <a:endParaRPr lang="en-US">
+              <a:hlinkClick r:id="rId2"/>
+            </a:endParaRPr>
           </a:p>
           <a:p>
             <a:pPr marL="0" indent="0">
               <a:buNone/>
             </a:pPr>
             <a:r>
-              <a:rPr lang="en-US" dirty="0">
+              <a:rPr lang="en-US">
                 <a:hlinkClick r:id="rId2"/>
               </a:rPr>
-              <a:t>https://bookvault-api-wth1.onrender.com/</a:t>
+              <a:t>https://bookvault-api-wth1.onrender.com/docs</a:t>
             </a:r>
             <a:endParaRPr lang="en-US" dirty="0"/>
           </a:p>

</xml_diff>